<commit_message>
slides(vqa-v2): refine Japanese wording and pair translations
</commit_message>
<xml_diff>
--- a/slides/datasets-in-10-minutes-vqa-v2.pptx
+++ b/slides/datasets-in-10-minutes-vqa-v2.pptx
@@ -11272,7 +11272,7 @@
                 <a:ea typeface="Noto Sans CJK JP"/>
                 <a:cs typeface="Noto Sans"/>
               </a:rPr>
-              <a:t>原著Table 1のval結果。MCBは画像と言語の特徴を組み合わせる方式。</a:t>
+              <a:t>Goyalら（2017）のval結果。MCBは画像と言語の特徴を組み合わせる方式。</a:t>
             </a:r>
           </a:p>
         </p:txBody>
@@ -28809,7 +28809,7 @@
                 <a:ea typeface="Noto Sans CJK JP"/>
                 <a:cs typeface="Noto Sans"/>
               </a:rPr>
-              <a:t>補完画像の収集、v1とv2の違い、モデルによる比較を説明する原著。</a:t>
+              <a:t>補完画像の収集、v1とv2の違い、モデルによる比較を説明する論文。</a:t>
             </a:r>
           </a:p>
           <a:p>

</xml_diff>

<commit_message>
Improve vqa-v2 answer visibility and citation wording
</commit_message>
<xml_diff>
--- a/slides/datasets-in-10-minutes-vqa-v2.pptx
+++ b/slides/datasets-in-10-minutes-vqa-v2.pptx
@@ -7894,7 +7894,7 @@
         <p:spPr>
           <a:xfrm>
             <a:off x="5010912" y="2803398"/>
-            <a:ext cx="3584448" cy="338835"/>
+            <a:ext cx="3584448" cy="386540"/>
           </a:xfrm>
           <a:prstGeom prst="rect">
             <a:avLst/>
@@ -7909,7 +7909,7 @@
           <a:p>
             <a:pPr algn="l">
               <a:lnSpc>
-                <a:spcPct val="119000"/>
+                <a:spcPts val="2640"/>
               </a:lnSpc>
               <a:spcBef>
                 <a:spcPts val="0"/>
@@ -7926,9 +7926,9 @@
               </a:defRPr>
             </a:pPr>
             <a:r>
-              <a:rPr sz="2000" b="1" lang="ja-JP" altLang="en-US">
-                <a:solidFill>
-                  <a:srgbClr val="303437"/>
+              <a:rPr sz="2200" b="1" lang="ja-JP" altLang="en-US">
+                <a:solidFill>
+                  <a:schemeClr val="accent1"/>
                 </a:solidFill>
                 <a:latin typeface="Noto Sans"/>
                 <a:ea typeface="Noto Sans CJK JP"/>
@@ -12186,7 +12186,7 @@
                 <a:ea typeface="Noto Sans CJK JP"/>
                 <a:cs typeface="Noto Sans"/>
               </a:rPr>
-              <a:t>BLIP-2論文Table 5。VQAの学習データで微調整した結果。非公開の正解を使い、サーバ側で採点。</a:t>
+              <a:t>VQAの学習データで微調整した結果。非公開の正解を使い、サーバ側で採点。</a:t>
             </a:r>
           </a:p>
         </p:txBody>
@@ -19598,7 +19598,7 @@
         <p:spPr>
           <a:xfrm>
             <a:off x="5010912" y="2803398"/>
-            <a:ext cx="3584448" cy="338835"/>
+            <a:ext cx="3584448" cy="386540"/>
           </a:xfrm>
           <a:prstGeom prst="rect">
             <a:avLst/>
@@ -19613,7 +19613,7 @@
           <a:p>
             <a:pPr algn="l">
               <a:lnSpc>
-                <a:spcPct val="119000"/>
+                <a:spcPts val="2640"/>
               </a:lnSpc>
               <a:spcBef>
                 <a:spcPts val="0"/>
@@ -19630,9 +19630,9 @@
               </a:defRPr>
             </a:pPr>
             <a:r>
-              <a:rPr sz="2000" b="1" lang="ja-JP" altLang="en-US">
-                <a:solidFill>
-                  <a:srgbClr val="303437"/>
+              <a:rPr sz="2200" b="1" lang="ja-JP" altLang="en-US">
+                <a:solidFill>
+                  <a:schemeClr val="accent1"/>
                 </a:solidFill>
                 <a:latin typeface="Noto Sans"/>
                 <a:ea typeface="Noto Sans CJK JP"/>
@@ -20154,7 +20154,7 @@
         <p:spPr>
           <a:xfrm>
             <a:off x="5010912" y="3377692"/>
-            <a:ext cx="3584448" cy="641095"/>
+            <a:ext cx="3584448" cy="720208"/>
           </a:xfrm>
           <a:prstGeom prst="rect">
             <a:avLst/>
@@ -20169,7 +20169,7 @@
           <a:p>
             <a:pPr algn="l">
               <a:lnSpc>
-                <a:spcPct val="119000"/>
+                <a:spcPts val="2640"/>
               </a:lnSpc>
               <a:spcBef>
                 <a:spcPts val="0"/>
@@ -20186,9 +20186,9 @@
               </a:defRPr>
             </a:pPr>
             <a:r>
-              <a:rPr sz="2000" b="1" lang="ja-JP" altLang="en-US">
-                <a:solidFill>
-                  <a:srgbClr val="303437"/>
+              <a:rPr sz="2200" b="1" lang="ja-JP" altLang="en-US">
+                <a:solidFill>
+                  <a:schemeClr val="accent1"/>
                 </a:solidFill>
                 <a:latin typeface="Noto Sans"/>
                 <a:ea typeface="Noto Sans CJK JP"/>
@@ -20200,7 +20200,7 @@
           <a:p>
             <a:pPr algn="l">
               <a:lnSpc>
-                <a:spcPct val="119000"/>
+                <a:spcPts val="2640"/>
               </a:lnSpc>
               <a:spcBef>
                 <a:spcPts val="0"/>
@@ -20217,9 +20217,9 @@
               </a:defRPr>
             </a:pPr>
             <a:r>
-              <a:rPr sz="2000" b="1" lang="ja-JP" altLang="en-US">
-                <a:solidFill>
-                  <a:srgbClr val="303437"/>
+              <a:rPr sz="2200" b="1" lang="ja-JP" altLang="en-US">
+                <a:solidFill>
+                  <a:schemeClr val="accent1"/>
                 </a:solidFill>
                 <a:latin typeface="Noto Sans"/>
                 <a:ea typeface="Noto Sans CJK JP"/>
@@ -20741,7 +20741,7 @@
         <p:spPr>
           <a:xfrm>
             <a:off x="5010912" y="2803398"/>
-            <a:ext cx="3584448" cy="338835"/>
+            <a:ext cx="3584448" cy="386540"/>
           </a:xfrm>
           <a:prstGeom prst="rect">
             <a:avLst/>
@@ -20756,7 +20756,7 @@
           <a:p>
             <a:pPr algn="l">
               <a:lnSpc>
-                <a:spcPct val="119000"/>
+                <a:spcPts val="2640"/>
               </a:lnSpc>
               <a:spcBef>
                 <a:spcPts val="0"/>
@@ -20773,9 +20773,9 @@
               </a:defRPr>
             </a:pPr>
             <a:r>
-              <a:rPr sz="2000" b="1" lang="ja-JP" altLang="en-US">
-                <a:solidFill>
-                  <a:srgbClr val="303437"/>
+              <a:rPr sz="2200" b="1" lang="ja-JP" altLang="en-US">
+                <a:solidFill>
+                  <a:schemeClr val="accent1"/>
                 </a:solidFill>
                 <a:latin typeface="Noto Sans"/>
                 <a:ea typeface="Noto Sans CJK JP"/>
@@ -21297,7 +21297,7 @@
         <p:spPr>
           <a:xfrm>
             <a:off x="5010912" y="3377692"/>
-            <a:ext cx="3584448" cy="338835"/>
+            <a:ext cx="3584448" cy="386439"/>
           </a:xfrm>
           <a:prstGeom prst="rect">
             <a:avLst/>
@@ -21312,7 +21312,7 @@
           <a:p>
             <a:pPr algn="l">
               <a:lnSpc>
-                <a:spcPct val="119000"/>
+                <a:spcPts val="2640"/>
               </a:lnSpc>
               <a:spcBef>
                 <a:spcPts val="0"/>
@@ -21329,9 +21329,9 @@
               </a:defRPr>
             </a:pPr>
             <a:r>
-              <a:rPr sz="2000" b="1" lang="ja-JP" altLang="en-US">
-                <a:solidFill>
-                  <a:srgbClr val="303437"/>
+              <a:rPr sz="2200" b="1" lang="ja-JP" altLang="en-US">
+                <a:solidFill>
+                  <a:schemeClr val="accent1"/>
                 </a:solidFill>
                 <a:latin typeface="Noto Sans"/>
                 <a:ea typeface="Noto Sans CJK JP"/>
@@ -21853,7 +21853,7 @@
         <p:spPr>
           <a:xfrm>
             <a:off x="5010912" y="2803398"/>
-            <a:ext cx="3584448" cy="338835"/>
+            <a:ext cx="3584448" cy="386540"/>
           </a:xfrm>
           <a:prstGeom prst="rect">
             <a:avLst/>
@@ -21868,7 +21868,7 @@
           <a:p>
             <a:pPr algn="l">
               <a:lnSpc>
-                <a:spcPct val="119000"/>
+                <a:spcPts val="2640"/>
               </a:lnSpc>
               <a:spcBef>
                 <a:spcPts val="0"/>
@@ -21885,9 +21885,9 @@
               </a:defRPr>
             </a:pPr>
             <a:r>
-              <a:rPr sz="2000" b="1" lang="ja-JP" altLang="en-US">
-                <a:solidFill>
-                  <a:srgbClr val="303437"/>
+              <a:rPr sz="2200" b="1" lang="ja-JP" altLang="en-US">
+                <a:solidFill>
+                  <a:schemeClr val="accent1"/>
                 </a:solidFill>
                 <a:latin typeface="Noto Sans"/>
                 <a:ea typeface="Noto Sans CJK JP"/>
@@ -22412,7 +22412,7 @@
         <p:spPr>
           <a:xfrm>
             <a:off x="5010912" y="3090545"/>
-            <a:ext cx="3584448" cy="338835"/>
+            <a:ext cx="3584448" cy="386667"/>
           </a:xfrm>
           <a:prstGeom prst="rect">
             <a:avLst/>
@@ -22427,7 +22427,7 @@
           <a:p>
             <a:pPr algn="l">
               <a:lnSpc>
-                <a:spcPct val="119000"/>
+                <a:spcPts val="2640"/>
               </a:lnSpc>
               <a:spcBef>
                 <a:spcPts val="0"/>
@@ -22444,9 +22444,9 @@
               </a:defRPr>
             </a:pPr>
             <a:r>
-              <a:rPr sz="2000" b="1" lang="ja-JP" altLang="en-US">
-                <a:solidFill>
-                  <a:srgbClr val="303437"/>
+              <a:rPr sz="2200" b="1" lang="ja-JP" altLang="en-US">
+                <a:solidFill>
+                  <a:schemeClr val="accent1"/>
                 </a:solidFill>
                 <a:latin typeface="Noto Sans"/>
                 <a:ea typeface="Noto Sans CJK JP"/>
@@ -23082,7 +23082,7 @@
         <p:spPr>
           <a:xfrm>
             <a:off x="5010912" y="3090545"/>
-            <a:ext cx="3584448" cy="338835"/>
+            <a:ext cx="3584448" cy="386667"/>
           </a:xfrm>
           <a:prstGeom prst="rect">
             <a:avLst/>
@@ -23097,7 +23097,7 @@
           <a:p>
             <a:pPr algn="l">
               <a:lnSpc>
-                <a:spcPct val="119000"/>
+                <a:spcPts val="2640"/>
               </a:lnSpc>
               <a:spcBef>
                 <a:spcPts val="0"/>
@@ -23114,9 +23114,9 @@
               </a:defRPr>
             </a:pPr>
             <a:r>
-              <a:rPr sz="2000" b="1" lang="ja-JP" altLang="en-US">
-                <a:solidFill>
-                  <a:srgbClr val="303437"/>
+              <a:rPr sz="2200" b="1" lang="ja-JP" altLang="en-US">
+                <a:solidFill>
+                  <a:schemeClr val="accent1"/>
                 </a:solidFill>
                 <a:latin typeface="Noto Sans"/>
                 <a:ea typeface="Noto Sans CJK JP"/>
@@ -23638,7 +23638,7 @@
         <p:spPr>
           <a:xfrm>
             <a:off x="5010912" y="3090545"/>
-            <a:ext cx="3584448" cy="338835"/>
+            <a:ext cx="3584448" cy="386667"/>
           </a:xfrm>
           <a:prstGeom prst="rect">
             <a:avLst/>
@@ -23653,7 +23653,7 @@
           <a:p>
             <a:pPr algn="l">
               <a:lnSpc>
-                <a:spcPct val="119000"/>
+                <a:spcPts val="2640"/>
               </a:lnSpc>
               <a:spcBef>
                 <a:spcPts val="0"/>
@@ -23670,9 +23670,9 @@
               </a:defRPr>
             </a:pPr>
             <a:r>
-              <a:rPr sz="2000" b="1" lang="ja-JP" altLang="en-US">
-                <a:solidFill>
-                  <a:srgbClr val="303437"/>
+              <a:rPr sz="2200" b="1" lang="ja-JP" altLang="en-US">
+                <a:solidFill>
+                  <a:schemeClr val="accent1"/>
                 </a:solidFill>
                 <a:latin typeface="Noto Sans"/>
                 <a:ea typeface="Noto Sans CJK JP"/>
@@ -24197,7 +24197,7 @@
         <p:spPr>
           <a:xfrm>
             <a:off x="5010912" y="2803398"/>
-            <a:ext cx="3584448" cy="338835"/>
+            <a:ext cx="3584448" cy="386540"/>
           </a:xfrm>
           <a:prstGeom prst="rect">
             <a:avLst/>
@@ -24212,7 +24212,7 @@
           <a:p>
             <a:pPr algn="l">
               <a:lnSpc>
-                <a:spcPct val="119000"/>
+                <a:spcPts val="2640"/>
               </a:lnSpc>
               <a:spcBef>
                 <a:spcPts val="0"/>
@@ -24229,9 +24229,9 @@
               </a:defRPr>
             </a:pPr>
             <a:r>
-              <a:rPr sz="2000" b="1" lang="ja-JP" altLang="en-US">
-                <a:solidFill>
-                  <a:srgbClr val="303437"/>
+              <a:rPr sz="2200" b="1" lang="ja-JP" altLang="en-US">
+                <a:solidFill>
+                  <a:schemeClr val="accent1"/>
                 </a:solidFill>
                 <a:latin typeface="Noto Sans"/>
                 <a:ea typeface="Noto Sans CJK JP"/>
@@ -24753,7 +24753,7 @@
         <p:spPr>
           <a:xfrm>
             <a:off x="5010912" y="3377692"/>
-            <a:ext cx="3584448" cy="338835"/>
+            <a:ext cx="3584448" cy="386439"/>
           </a:xfrm>
           <a:prstGeom prst="rect">
             <a:avLst/>
@@ -24768,7 +24768,7 @@
           <a:p>
             <a:pPr algn="l">
               <a:lnSpc>
-                <a:spcPct val="119000"/>
+                <a:spcPts val="2640"/>
               </a:lnSpc>
               <a:spcBef>
                 <a:spcPts val="0"/>
@@ -24785,9 +24785,9 @@
               </a:defRPr>
             </a:pPr>
             <a:r>
-              <a:rPr sz="2000" b="1" lang="ja-JP" altLang="en-US">
-                <a:solidFill>
-                  <a:srgbClr val="303437"/>
+              <a:rPr sz="2200" b="1" lang="ja-JP" altLang="en-US">
+                <a:solidFill>
+                  <a:schemeClr val="accent1"/>
                 </a:solidFill>
                 <a:latin typeface="Noto Sans"/>
                 <a:ea typeface="Noto Sans CJK JP"/>
@@ -29847,7 +29847,7 @@
         <p:spPr>
           <a:xfrm>
             <a:off x="5010912" y="3090545"/>
-            <a:ext cx="3584448" cy="338835"/>
+            <a:ext cx="3584448" cy="386667"/>
           </a:xfrm>
           <a:prstGeom prst="rect">
             <a:avLst/>
@@ -29862,7 +29862,7 @@
           <a:p>
             <a:pPr algn="l">
               <a:lnSpc>
-                <a:spcPct val="119000"/>
+                <a:spcPts val="2640"/>
               </a:lnSpc>
               <a:spcBef>
                 <a:spcPts val="0"/>
@@ -29879,9 +29879,9 @@
               </a:defRPr>
             </a:pPr>
             <a:r>
-              <a:rPr sz="2000" b="1" lang="ja-JP" altLang="en-US">
-                <a:solidFill>
-                  <a:srgbClr val="303437"/>
+              <a:rPr sz="2200" b="1" lang="ja-JP" altLang="en-US">
+                <a:solidFill>
+                  <a:schemeClr val="accent1"/>
                 </a:solidFill>
                 <a:latin typeface="Noto Sans"/>
                 <a:ea typeface="Noto Sans CJK JP"/>
@@ -30403,7 +30403,7 @@
         <p:spPr>
           <a:xfrm>
             <a:off x="5010912" y="3090545"/>
-            <a:ext cx="3584448" cy="338835"/>
+            <a:ext cx="3584448" cy="386667"/>
           </a:xfrm>
           <a:prstGeom prst="rect">
             <a:avLst/>
@@ -30418,7 +30418,7 @@
           <a:p>
             <a:pPr algn="l">
               <a:lnSpc>
-                <a:spcPct val="119000"/>
+                <a:spcPts val="2640"/>
               </a:lnSpc>
               <a:spcBef>
                 <a:spcPts val="0"/>
@@ -30435,9 +30435,9 @@
               </a:defRPr>
             </a:pPr>
             <a:r>
-              <a:rPr sz="2000" b="1" lang="ja-JP" altLang="en-US">
-                <a:solidFill>
-                  <a:srgbClr val="303437"/>
+              <a:rPr sz="2200" b="1" lang="ja-JP" altLang="en-US">
+                <a:solidFill>
+                  <a:schemeClr val="accent1"/>
                 </a:solidFill>
                 <a:latin typeface="Noto Sans"/>
                 <a:ea typeface="Noto Sans CJK JP"/>
@@ -31263,7 +31263,7 @@
         <p:spPr>
           <a:xfrm>
             <a:off x="5010912" y="3090545"/>
-            <a:ext cx="3584448" cy="338835"/>
+            <a:ext cx="3584448" cy="386667"/>
           </a:xfrm>
           <a:prstGeom prst="rect">
             <a:avLst/>
@@ -31278,7 +31278,7 @@
           <a:p>
             <a:pPr algn="l">
               <a:lnSpc>
-                <a:spcPct val="119000"/>
+                <a:spcPts val="2640"/>
               </a:lnSpc>
               <a:spcBef>
                 <a:spcPts val="0"/>
@@ -31295,9 +31295,9 @@
               </a:defRPr>
             </a:pPr>
             <a:r>
-              <a:rPr sz="2000" b="1" lang="ja-JP" altLang="en-US">
-                <a:solidFill>
-                  <a:srgbClr val="303437"/>
+              <a:rPr sz="2200" b="1" lang="ja-JP" altLang="en-US">
+                <a:solidFill>
+                  <a:schemeClr val="accent1"/>
                 </a:solidFill>
                 <a:latin typeface="Noto Sans"/>
                 <a:ea typeface="Noto Sans CJK JP"/>

</xml_diff>